<commit_message>
Manuel chef de projet : la slide « Soumettre et vérifier l'envoi » montre le choix des périmètres
Co-Authored-By: Claude Opus 5.5 <noreply@anthropic.com>
Claude-Session: https://claude.ai/code/session_01THjf6i97sjipVrw4G2ijeJ
</commit_message>
<xml_diff>
--- a/docs/Manuel_Project_Navigator_chef_de_projet.pptx
+++ b/docs/Manuel_Project_Navigator_chef_de_projet.pptx
@@ -29694,14 +29694,14 @@
       </p:sp>
       <p:pic>
         <p:nvPicPr>
-          <p:cNvPr id="6" name="Picture 5" descr="48-home-submitted_1200.jpg"/>
+          <p:cNvPr id="6" name="Picture 5" descr="Choix des périmètres à consulter"/>
           <p:cNvPicPr>
             <a:picLocks noChangeAspect="1"/>
           </p:cNvPicPr>
           <p:nvPr/>
         </p:nvPicPr>
         <p:blipFill>
-          <a:blip r:embed="rId2"/>
+          <a:blip r:embed="rIdVagues1"/>
           <a:stretch>
             <a:fillRect/>
           </a:stretch>
@@ -29709,7 +29709,7 @@
         <p:spPr>
           <a:xfrm>
             <a:off x="548640" y="1188720"/>
-            <a:ext cx="4572000" cy="3429000"/>
+            <a:ext cx="2333456" cy="3200400"/>
           </a:xfrm>
           <a:prstGeom prst="rect">
             <a:avLst/>
@@ -29721,9 +29721,38 @@
           </a:ln>
         </p:spPr>
       </p:pic>
-      <p:sp>
-        <p:nvSpPr>
-          <p:cNvPr id="7" name="Oval 6"/>
+      <p:pic>
+        <p:nvPicPr>
+          <p:cNvPr id="7" name="Picture 6" descr="Consultation partielle après l’envoi"/>
+          <p:cNvPicPr>
+            <a:picLocks noChangeAspect="1"/>
+          </p:cNvPicPr>
+          <p:nvPr/>
+        </p:nvPicPr>
+        <p:blipFill>
+          <a:blip r:embed="rIdVagues2"/>
+          <a:stretch>
+            <a:fillRect/>
+          </a:stretch>
+        </p:blipFill>
+        <p:spPr>
+          <a:xfrm>
+            <a:off x="3019256" y="1188720"/>
+            <a:ext cx="2231755" cy="3200400"/>
+          </a:xfrm>
+          <a:prstGeom prst="rect">
+            <a:avLst/>
+          </a:prstGeom>
+          <a:ln w="9525">
+            <a:solidFill>
+              <a:srgbClr val="D5DCE4"/>
+            </a:solidFill>
+          </a:ln>
+        </p:spPr>
+      </p:pic>
+      <p:sp>
+        <p:nvSpPr>
+          <p:cNvPr id="8" name="Oval 6"/>
           <p:cNvSpPr/>
           <p:nvPr/>
         </p:nvSpPr>
@@ -29776,14 +29805,14 @@
       </p:sp>
       <p:sp>
         <p:nvSpPr>
-          <p:cNvPr id="8" name="TextBox 7"/>
+          <p:cNvPr id="9" name="TextBox 7"/>
           <p:cNvSpPr txBox="1"/>
           <p:nvPr/>
         </p:nvSpPr>
         <p:spPr>
           <a:xfrm>
             <a:off x="5724144" y="1234440"/>
-            <a:ext cx="2871216" cy="512064"/>
+            <a:ext cx="2871216" cy="360000"/>
           </a:xfrm>
           <a:prstGeom prst="rect">
             <a:avLst/>
@@ -29804,7 +29833,7 @@
                 </a:solidFill>
                 <a:latin typeface="Roboto"/>
               </a:rPr>
-              <a:t>Message de confirmation </a:t>
+              <a:t>« Qui voulez-vous consulter ? » </a:t>
             </a:r>
             <a:r>
               <a:rPr sz="1050" b="0" i="0">
@@ -29813,20 +29842,311 @@
                 </a:solidFill>
                 <a:latin typeface="Roboto"/>
               </a:rPr>
-              <a:t>: « Projet soumis : … a bien été envoyé pour analyse » ou « Avis préliminaire demandé : … ».</a:t>
-            </a:r>
-          </a:p>
-        </p:txBody>
-      </p:sp>
-      <p:sp>
-        <p:nvSpPr>
-          <p:cNvPr id="9" name="Oval 8"/>
+              <a:t>: tous les périmètres (par défaut) ou certains d’abord.</a:t>
+            </a:r>
+          </a:p>
+        </p:txBody>
+      </p:sp>
+      <p:sp>
+        <p:nvSpPr>
+          <p:cNvPr id="10" name="Oval 6"/>
           <p:cNvSpPr/>
           <p:nvPr/>
         </p:nvSpPr>
         <p:spPr>
           <a:xfrm>
-            <a:off x="5394960" y="2250566"/>
+            <a:off x="5394960" y="1705296"/>
+            <a:ext cx="237744" cy="237744"/>
+          </a:xfrm>
+          <a:prstGeom prst="ellipse">
+            <a:avLst/>
+          </a:prstGeom>
+          <a:solidFill>
+            <a:srgbClr val="C8102E"/>
+          </a:solidFill>
+          <a:ln>
+            <a:noFill/>
+          </a:ln>
+          <a:effectLst/>
+        </p:spPr>
+        <p:style>
+          <a:lnRef idx="1">
+            <a:schemeClr val="accent1"/>
+          </a:lnRef>
+          <a:fillRef idx="3">
+            <a:schemeClr val="accent1"/>
+          </a:fillRef>
+          <a:effectRef idx="0">
+            <a:schemeClr val="accent1"/>
+          </a:effectRef>
+          <a:fontRef idx="minor">
+            <a:schemeClr val="lt1"/>
+          </a:fontRef>
+        </p:style>
+        <p:txBody>
+          <a:bodyPr rtlCol="0" anchor="ctr" lIns="0" rIns="0" tIns="0" bIns="0"/>
+          <a:lstStyle/>
+          <a:p>
+            <a:pPr algn="ctr"/>
+            <a:r>
+              <a:rPr sz="1000" b="1">
+                <a:solidFill>
+                  <a:srgbClr val="FFFFFF"/>
+                </a:solidFill>
+                <a:latin typeface="Roboto"/>
+              </a:rPr>
+              <a:t>2</a:t>
+            </a:r>
+          </a:p>
+        </p:txBody>
+      </p:sp>
+      <p:sp>
+        <p:nvSpPr>
+          <p:cNvPr id="11" name="TextBox 7"/>
+          <p:cNvSpPr txBox="1"/>
+          <p:nvPr/>
+        </p:nvSpPr>
+        <p:spPr>
+          <a:xfrm>
+            <a:off x="5724144" y="1714440"/>
+            <a:ext cx="2871216" cy="180000"/>
+          </a:xfrm>
+          <a:prstGeom prst="rect">
+            <a:avLst/>
+          </a:prstGeom>
+          <a:noFill/>
+        </p:spPr>
+        <p:txBody>
+          <a:bodyPr wrap="square" lIns="0" rIns="0" tIns="0" bIns="0" anchor="t">
+            <a:spAutoFit/>
+          </a:bodyPr>
+          <a:lstStyle/>
+          <a:p>
+            <a:pPr algn="l"/>
+            <a:r>
+              <a:rPr sz="1050" b="1" i="0">
+                <a:solidFill>
+                  <a:srgbClr val="1F2A37"/>
+                </a:solidFill>
+                <a:latin typeface="Roboto"/>
+              </a:rPr>
+              <a:t>Cochez </a:t>
+            </a:r>
+            <a:r>
+              <a:rPr sz="1050" b="0" i="0">
+                <a:solidFill>
+                  <a:srgbClr val="1F2A37"/>
+                </a:solidFill>
+                <a:latin typeface="Roboto"/>
+              </a:rPr>
+              <a:t>qui consulter en premier.</a:t>
+            </a:r>
+          </a:p>
+        </p:txBody>
+      </p:sp>
+      <p:sp>
+        <p:nvSpPr>
+          <p:cNvPr id="12" name="Oval 6"/>
+          <p:cNvSpPr/>
+          <p:nvPr/>
+        </p:nvSpPr>
+        <p:spPr>
+          <a:xfrm>
+            <a:off x="5394960" y="2063040"/>
+            <a:ext cx="237744" cy="237744"/>
+          </a:xfrm>
+          <a:prstGeom prst="ellipse">
+            <a:avLst/>
+          </a:prstGeom>
+          <a:solidFill>
+            <a:srgbClr val="C8102E"/>
+          </a:solidFill>
+          <a:ln>
+            <a:noFill/>
+          </a:ln>
+          <a:effectLst/>
+        </p:spPr>
+        <p:style>
+          <a:lnRef idx="1">
+            <a:schemeClr val="accent1"/>
+          </a:lnRef>
+          <a:fillRef idx="3">
+            <a:schemeClr val="accent1"/>
+          </a:fillRef>
+          <a:effectRef idx="0">
+            <a:schemeClr val="accent1"/>
+          </a:effectRef>
+          <a:fontRef idx="minor">
+            <a:schemeClr val="lt1"/>
+          </a:fontRef>
+        </p:style>
+        <p:txBody>
+          <a:bodyPr rtlCol="0" anchor="ctr" lIns="0" rIns="0" tIns="0" bIns="0"/>
+          <a:lstStyle/>
+          <a:p>
+            <a:pPr algn="ctr"/>
+            <a:r>
+              <a:rPr sz="1000" b="1">
+                <a:solidFill>
+                  <a:srgbClr val="FFFFFF"/>
+                </a:solidFill>
+                <a:latin typeface="Roboto"/>
+              </a:rPr>
+              <a:t>3</a:t>
+            </a:r>
+          </a:p>
+        </p:txBody>
+      </p:sp>
+      <p:sp>
+        <p:nvSpPr>
+          <p:cNvPr id="13" name="TextBox 7"/>
+          <p:cNvSpPr txBox="1"/>
+          <p:nvPr/>
+        </p:nvSpPr>
+        <p:spPr>
+          <a:xfrm>
+            <a:off x="5724144" y="2072184"/>
+            <a:ext cx="2871216" cy="360000"/>
+          </a:xfrm>
+          <a:prstGeom prst="rect">
+            <a:avLst/>
+          </a:prstGeom>
+          <a:noFill/>
+        </p:spPr>
+        <p:txBody>
+          <a:bodyPr wrap="square" lIns="0" rIns="0" tIns="0" bIns="0" anchor="t">
+            <a:spAutoFit/>
+          </a:bodyPr>
+          <a:lstStyle/>
+          <a:p>
+            <a:pPr algn="l"/>
+            <a:r>
+              <a:rPr sz="1050" b="1" i="0">
+                <a:solidFill>
+                  <a:srgbClr val="1F2A37"/>
+                </a:solidFill>
+                <a:latin typeface="Roboto"/>
+              </a:rPr>
+              <a:t>Le bouton annonce l’envoi </a:t>
+            </a:r>
+            <a:r>
+              <a:rPr sz="1050" b="0" i="0">
+                <a:solidFill>
+                  <a:srgbClr val="1F2A37"/>
+                </a:solidFill>
+                <a:latin typeface="Roboto"/>
+              </a:rPr>
+              <a:t>: à qui, et combien attendront.</a:t>
+            </a:r>
+          </a:p>
+        </p:txBody>
+      </p:sp>
+      <p:sp>
+        <p:nvSpPr>
+          <p:cNvPr id="14" name="Oval 6"/>
+          <p:cNvSpPr/>
+          <p:nvPr/>
+        </p:nvSpPr>
+        <p:spPr>
+          <a:xfrm>
+            <a:off x="5394960" y="2543040"/>
+            <a:ext cx="237744" cy="237744"/>
+          </a:xfrm>
+          <a:prstGeom prst="ellipse">
+            <a:avLst/>
+          </a:prstGeom>
+          <a:solidFill>
+            <a:srgbClr val="C8102E"/>
+          </a:solidFill>
+          <a:ln>
+            <a:noFill/>
+          </a:ln>
+          <a:effectLst/>
+        </p:spPr>
+        <p:style>
+          <a:lnRef idx="1">
+            <a:schemeClr val="accent1"/>
+          </a:lnRef>
+          <a:fillRef idx="3">
+            <a:schemeClr val="accent1"/>
+          </a:fillRef>
+          <a:effectRef idx="0">
+            <a:schemeClr val="accent1"/>
+          </a:effectRef>
+          <a:fontRef idx="minor">
+            <a:schemeClr val="lt1"/>
+          </a:fontRef>
+        </p:style>
+        <p:txBody>
+          <a:bodyPr rtlCol="0" anchor="ctr" lIns="0" rIns="0" tIns="0" bIns="0"/>
+          <a:lstStyle/>
+          <a:p>
+            <a:pPr algn="ctr"/>
+            <a:r>
+              <a:rPr sz="1000" b="1">
+                <a:solidFill>
+                  <a:srgbClr val="FFFFFF"/>
+                </a:solidFill>
+                <a:latin typeface="Roboto"/>
+              </a:rPr>
+              <a:t>4</a:t>
+            </a:r>
+          </a:p>
+        </p:txBody>
+      </p:sp>
+      <p:sp>
+        <p:nvSpPr>
+          <p:cNvPr id="15" name="TextBox 7"/>
+          <p:cNvSpPr txBox="1"/>
+          <p:nvPr/>
+        </p:nvSpPr>
+        <p:spPr>
+          <a:xfrm>
+            <a:off x="5724144" y="2552184"/>
+            <a:ext cx="2871216" cy="360000"/>
+          </a:xfrm>
+          <a:prstGeom prst="rect">
+            <a:avLst/>
+          </a:prstGeom>
+          <a:noFill/>
+        </p:spPr>
+        <p:txBody>
+          <a:bodyPr wrap="square" lIns="0" rIns="0" tIns="0" bIns="0" anchor="t">
+            <a:spAutoFit/>
+          </a:bodyPr>
+          <a:lstStyle/>
+          <a:p>
+            <a:pPr algn="l"/>
+            <a:r>
+              <a:rPr sz="1050" b="1" i="0">
+                <a:solidFill>
+                  <a:srgbClr val="1F2A37"/>
+                </a:solidFill>
+                <a:latin typeface="Roboto"/>
+              </a:rPr>
+              <a:t>Après l’envoi </a:t>
+            </a:r>
+            <a:r>
+              <a:rPr sz="1050" b="0" i="0">
+                <a:solidFill>
+                  <a:srgbClr val="1F2A37"/>
+                </a:solidFill>
+                <a:latin typeface="Roboto"/>
+              </a:rPr>
+              <a:t>: « Consultation partielle » et les périmètres à solliciter ensuite.</a:t>
+            </a:r>
+          </a:p>
+        </p:txBody>
+      </p:sp>
+      <p:sp>
+        <p:nvSpPr>
+          <p:cNvPr id="16" name="Oval 8"/>
+          <p:cNvSpPr/>
+          <p:nvPr/>
+        </p:nvSpPr>
+        <p:spPr>
+          <a:xfrm>
+            <a:off x="5394960" y="3139046"/>
             <a:ext cx="73152" cy="73152"/>
           </a:xfrm>
           <a:prstGeom prst="ellipse">
@@ -29864,14 +30184,14 @@
       </p:sp>
       <p:sp>
         <p:nvSpPr>
-          <p:cNvPr id="10" name="TextBox 9"/>
-          <p:cNvSpPr txBox="1"/>
-          <p:nvPr/>
-        </p:nvSpPr>
-        <p:spPr>
-          <a:xfrm>
-            <a:off x="5577840" y="2194560"/>
-            <a:ext cx="3017520" cy="170687"/>
+          <p:cNvPr id="17" name="TextBox 9"/>
+          <p:cNvSpPr txBox="1"/>
+          <p:nvPr/>
+        </p:nvSpPr>
+        <p:spPr>
+          <a:xfrm>
+            <a:off x="5577840" y="3083040"/>
+            <a:ext cx="3017520" cy="360000"/>
           </a:xfrm>
           <a:prstGeom prst="rect">
             <a:avLst/>
@@ -29892,20 +30212,20 @@
                 </a:solidFill>
                 <a:latin typeface="Roboto"/>
               </a:rPr>
-              <a:t>Le projet passe dans « Projets soumis ».</a:t>
-            </a:r>
-          </a:p>
-        </p:txBody>
-      </p:sp>
-      <p:sp>
-        <p:nvSpPr>
-          <p:cNvPr id="11" name="Oval 10"/>
+              <a:t>Confirmation : « Avis préliminaire demandé : … » ou « Projet soumis : … ».</a:t>
+            </a:r>
+          </a:p>
+        </p:txBody>
+      </p:sp>
+      <p:sp>
+        <p:nvSpPr>
+          <p:cNvPr id="18" name="Oval 8"/>
           <p:cNvSpPr/>
           <p:nvPr/>
         </p:nvSpPr>
         <p:spPr>
           <a:xfrm>
-            <a:off x="5394960" y="2494406"/>
+            <a:off x="5394960" y="3589046"/>
             <a:ext cx="73152" cy="73152"/>
           </a:xfrm>
           <a:prstGeom prst="ellipse">
@@ -29943,14 +30263,14 @@
       </p:sp>
       <p:sp>
         <p:nvSpPr>
-          <p:cNvPr id="12" name="TextBox 11"/>
-          <p:cNvSpPr txBox="1"/>
-          <p:nvPr/>
-        </p:nvSpPr>
-        <p:spPr>
-          <a:xfrm>
-            <a:off x="5577840" y="2438400"/>
-            <a:ext cx="3017520" cy="170687"/>
+          <p:cNvPr id="19" name="TextBox 9"/>
+          <p:cNvSpPr txBox="1"/>
+          <p:nvPr/>
+        </p:nvSpPr>
+        <p:spPr>
+          <a:xfrm>
+            <a:off x="5577840" y="3533040"/>
+            <a:ext cx="3017520" cy="180000"/>
           </a:xfrm>
           <a:prstGeom prst="rect">
             <a:avLst/>
@@ -29971,20 +30291,20 @@
                 </a:solidFill>
                 <a:latin typeface="Roboto"/>
               </a:rPr>
-              <a:t>Les équipes concernées sont notifiées.</a:t>
-            </a:r>
-          </a:p>
-        </p:txBody>
-      </p:sp>
-      <p:sp>
-        <p:nvSpPr>
-          <p:cNvPr id="13" name="Oval 12"/>
+              <a:t>Seuls les périmètres retenus sont notifiés.</a:t>
+            </a:r>
+          </a:p>
+        </p:txBody>
+      </p:sp>
+      <p:sp>
+        <p:nvSpPr>
+          <p:cNvPr id="20" name="Oval 8"/>
           <p:cNvSpPr/>
           <p:nvPr/>
         </p:nvSpPr>
         <p:spPr>
           <a:xfrm>
-            <a:off x="5394960" y="2738246"/>
+            <a:off x="5394960" y="3859046"/>
             <a:ext cx="73152" cy="73152"/>
           </a:xfrm>
           <a:prstGeom prst="ellipse">
@@ -30022,14 +30342,14 @@
       </p:sp>
       <p:sp>
         <p:nvSpPr>
-          <p:cNvPr id="14" name="TextBox 13"/>
-          <p:cNvSpPr txBox="1"/>
-          <p:nvPr/>
-        </p:nvSpPr>
-        <p:spPr>
-          <a:xfrm>
-            <a:off x="5577840" y="2682240"/>
-            <a:ext cx="3017520" cy="341375"/>
+          <p:cNvPr id="21" name="TextBox 9"/>
+          <p:cNvSpPr txBox="1"/>
+          <p:nvPr/>
+        </p:nvSpPr>
+        <p:spPr>
+          <a:xfrm>
+            <a:off x="5577840" y="3803040"/>
+            <a:ext cx="3017520" cy="360000"/>
           </a:xfrm>
           <a:prstGeom prst="rect">
             <a:avLst/>

</xml_diff>